<commit_message>
LLP307 bilingual: fix blank graphic slides (re-insert images + rebuild SmartArt as text)
</commit_message>
<xml_diff>
--- a/LLP307_EAP_写作课_中英对照.pptx
+++ b/LLP307_EAP_写作课_中英对照.pptx
@@ -5444,66 +5444,6 @@
           <a:chExt cx="0" cy="0"/>
         </a:xfrm>
       </p:grpSpPr>
-      <p:pic>
-        <p:nvPicPr>
-          <p:cNvPr id="7" name="Picture 6" descr="A screenshot of a computer&#10;&#10;AI-generated content may be incorrect."/>
-          <p:cNvPicPr>
-            <a:picLocks noChangeAspect="1"/>
-          </p:cNvPicPr>
-          <p:nvPr/>
-        </p:nvPicPr>
-        <p:blipFill>
-          <a:blip r:embed="rId1">
-            <a:extLst>
-              <a:ext uri="{28A0092B-C50C-407E-A947-70E740481C1C}">
-                <a14:useLocalDpi xmlns:a14="http://schemas.microsoft.com/office/drawing/2010/main" val="0"/>
-              </a:ext>
-            </a:extLst>
-          </a:blip>
-          <a:stretch>
-            <a:fillRect/>
-          </a:stretch>
-        </p:blipFill>
-        <p:spPr>
-          <a:xfrm>
-            <a:off x="6605587" y="1339239"/>
-            <a:ext cx="5473865" cy="5244122"/>
-          </a:xfrm>
-          <a:prstGeom prst="rect">
-            <a:avLst/>
-          </a:prstGeom>
-        </p:spPr>
-      </p:pic>
-      <p:pic>
-        <p:nvPicPr>
-          <p:cNvPr id="5" name="Picture 4" descr="A screenshot of a computer&#10;&#10;AI-generated content may be incorrect."/>
-          <p:cNvPicPr>
-            <a:picLocks noChangeAspect="1"/>
-          </p:cNvPicPr>
-          <p:nvPr/>
-        </p:nvPicPr>
-        <p:blipFill>
-          <a:blip r:embed="rId2">
-            <a:extLst>
-              <a:ext uri="{28A0092B-C50C-407E-A947-70E740481C1C}">
-                <a14:useLocalDpi xmlns:a14="http://schemas.microsoft.com/office/drawing/2010/main" val="0"/>
-              </a:ext>
-            </a:extLst>
-          </a:blip>
-          <a:stretch>
-            <a:fillRect/>
-          </a:stretch>
-        </p:blipFill>
-        <p:spPr>
-          <a:xfrm>
-            <a:off x="609600" y="1417639"/>
-            <a:ext cx="4976813" cy="4611133"/>
-          </a:xfrm>
-          <a:prstGeom prst="rect">
-            <a:avLst/>
-          </a:prstGeom>
-        </p:spPr>
-      </p:pic>
       <p:sp>
         <p:nvSpPr>
           <p:cNvPr id="2" name="Title 1"/>
@@ -5625,9 +5565,57 @@
           </a:p>
         </p:txBody>
       </p:sp>
-      <p:sp>
-        <p:nvSpPr>
-          <p:cNvPr id="10" name="TextBox 9"/>
+      <p:pic>
+        <p:nvPicPr>
+          <p:cNvPr id="10" name="Picture 9" descr="s17_1.png"/>
+          <p:cNvPicPr>
+            <a:picLocks noChangeAspect="1"/>
+          </p:cNvPicPr>
+          <p:nvPr/>
+        </p:nvPicPr>
+        <p:blipFill>
+          <a:blip r:embed="rId2"/>
+          <a:stretch>
+            <a:fillRect/>
+          </a:stretch>
+        </p:blipFill>
+        <p:spPr>
+          <a:xfrm>
+            <a:off x="612648" y="1417320"/>
+            <a:ext cx="4974336" cy="4608576"/>
+          </a:xfrm>
+          <a:prstGeom prst="rect">
+            <a:avLst/>
+          </a:prstGeom>
+        </p:spPr>
+      </p:pic>
+      <p:pic>
+        <p:nvPicPr>
+          <p:cNvPr id="11" name="Picture 10" descr="s17_0.png"/>
+          <p:cNvPicPr>
+            <a:picLocks noChangeAspect="1"/>
+          </p:cNvPicPr>
+          <p:nvPr/>
+        </p:nvPicPr>
+        <p:blipFill>
+          <a:blip r:embed="rId3"/>
+          <a:stretch>
+            <a:fillRect/>
+          </a:stretch>
+        </p:blipFill>
+        <p:spPr>
+          <a:xfrm>
+            <a:off x="6601968" y="1335024"/>
+            <a:ext cx="5477256" cy="5248656"/>
+          </a:xfrm>
+          <a:prstGeom prst="rect">
+            <a:avLst/>
+          </a:prstGeom>
+        </p:spPr>
+      </p:pic>
+      <p:sp>
+        <p:nvSpPr>
+          <p:cNvPr id="12" name="TextBox 11"/>
           <p:cNvSpPr txBox="1"/>
           <p:nvPr/>
         </p:nvSpPr>
@@ -5739,28 +5727,22 @@
       </p:sp>
       <p:pic>
         <p:nvPicPr>
-          <p:cNvPr id="4" name="Picture 3" descr="A screenshot of a computer&#10;&#10;AI-generated content may be incorrect."/>
+          <p:cNvPr id="3" name="Picture 2" descr="s18_1.png"/>
           <p:cNvPicPr>
             <a:picLocks noChangeAspect="1"/>
           </p:cNvPicPr>
           <p:nvPr/>
         </p:nvPicPr>
         <p:blipFill>
-          <a:blip r:embed="rId1">
-            <a:extLst>
-              <a:ext uri="{28A0092B-C50C-407E-A947-70E740481C1C}">
-                <a14:useLocalDpi xmlns:a14="http://schemas.microsoft.com/office/drawing/2010/main" val="0"/>
-              </a:ext>
-            </a:extLst>
-          </a:blip>
+          <a:blip r:embed="rId2"/>
           <a:stretch>
             <a:fillRect/>
           </a:stretch>
         </p:blipFill>
         <p:spPr>
           <a:xfrm>
-            <a:off x="6009829" y="0"/>
-            <a:ext cx="6182171" cy="6858000"/>
+            <a:off x="6007608" y="0"/>
+            <a:ext cx="6181344" cy="6858000"/>
           </a:xfrm>
           <a:prstGeom prst="rect">
             <a:avLst/>
@@ -5769,7 +5751,7 @@
       </p:pic>
       <p:sp>
         <p:nvSpPr>
-          <p:cNvPr id="5" name="TextBox 4"/>
+          <p:cNvPr id="4" name="TextBox 3"/>
           <p:cNvSpPr txBox="1"/>
           <p:nvPr/>
         </p:nvSpPr>
@@ -22877,31 +22859,6 @@
           </a:p>
         </p:txBody>
       </p:sp>
-      <p:pic>
-        <p:nvPicPr>
-          <p:cNvPr id="10" name="Picture 9"/>
-          <p:cNvPicPr>
-            <a:picLocks noChangeAspect="1"/>
-          </p:cNvPicPr>
-          <p:nvPr/>
-        </p:nvPicPr>
-        <p:blipFill rotWithShape="1">
-          <a:blip r:embed="rId1"/>
-          <a:srcRect r="46866"/>
-          <a:stretch>
-            <a:fillRect/>
-          </a:stretch>
-        </p:blipFill>
-        <p:spPr>
-          <a:xfrm>
-            <a:off x="2485025" y="1401615"/>
-            <a:ext cx="2173838" cy="4319810"/>
-          </a:xfrm>
-          <a:prstGeom prst="rect">
-            <a:avLst/>
-          </a:prstGeom>
-        </p:spPr>
-      </p:pic>
       <p:sp>
         <p:nvSpPr>
           <p:cNvPr id="11" name="Oval 10"/>
@@ -22946,30 +22903,6 @@
           </a:p>
         </p:txBody>
       </p:sp>
-      <p:pic>
-        <p:nvPicPr>
-          <p:cNvPr id="12" name="Picture 11"/>
-          <p:cNvPicPr>
-            <a:picLocks noChangeAspect="1"/>
-          </p:cNvPicPr>
-          <p:nvPr/>
-        </p:nvPicPr>
-        <p:blipFill>
-          <a:blip r:embed="rId2"/>
-          <a:stretch>
-            <a:fillRect/>
-          </a:stretch>
-        </p:blipFill>
-        <p:spPr>
-          <a:xfrm>
-            <a:off x="4960459" y="1492664"/>
-            <a:ext cx="4915310" cy="3925111"/>
-          </a:xfrm>
-          <a:prstGeom prst="rect">
-            <a:avLst/>
-          </a:prstGeom>
-        </p:spPr>
-      </p:pic>
       <p:cxnSp>
         <p:nvCxnSpPr>
           <p:cNvPr id="13" name="Straight Arrow Connector 12"/>
@@ -23044,9 +22977,57 @@
           </a:fontRef>
         </p:style>
       </p:cxnSp>
-      <p:sp>
-        <p:nvSpPr>
-          <p:cNvPr id="15" name="TextBox 14"/>
+      <p:pic>
+        <p:nvPicPr>
+          <p:cNvPr id="15" name="Picture 14" descr="s46_1.png"/>
+          <p:cNvPicPr>
+            <a:picLocks noChangeAspect="1"/>
+          </p:cNvPicPr>
+          <p:nvPr/>
+        </p:nvPicPr>
+        <p:blipFill>
+          <a:blip r:embed="rId2"/>
+          <a:stretch>
+            <a:fillRect/>
+          </a:stretch>
+        </p:blipFill>
+        <p:spPr>
+          <a:xfrm>
+            <a:off x="2487168" y="1399032"/>
+            <a:ext cx="2176272" cy="4315968"/>
+          </a:xfrm>
+          <a:prstGeom prst="rect">
+            <a:avLst/>
+          </a:prstGeom>
+        </p:spPr>
+      </p:pic>
+      <p:pic>
+        <p:nvPicPr>
+          <p:cNvPr id="16" name="Picture 15" descr="s46_3.png"/>
+          <p:cNvPicPr>
+            <a:picLocks noChangeAspect="1"/>
+          </p:cNvPicPr>
+          <p:nvPr/>
+        </p:nvPicPr>
+        <p:blipFill>
+          <a:blip r:embed="rId3"/>
+          <a:stretch>
+            <a:fillRect/>
+          </a:stretch>
+        </p:blipFill>
+        <p:spPr>
+          <a:xfrm>
+            <a:off x="4956048" y="1490472"/>
+            <a:ext cx="4919472" cy="3922776"/>
+          </a:xfrm>
+          <a:prstGeom prst="rect">
+            <a:avLst/>
+          </a:prstGeom>
+        </p:spPr>
+      </p:pic>
+      <p:sp>
+        <p:nvSpPr>
+          <p:cNvPr id="17" name="TextBox 16"/>
           <p:cNvSpPr txBox="1"/>
           <p:nvPr/>
         </p:nvSpPr>
@@ -24602,52 +24583,21 @@
         <p:nvPr/>
       </p:nvGrpSpPr>
       <p:grpSpPr/>
-      <p:nvGrpSpPr>
-        <p:cNvPr id="1" name=""/>
-        <p:cNvGrpSpPr/>
-        <p:nvPr/>
-      </p:nvGrpSpPr>
-      <p:grpSpPr>
-        <a:xfrm>
-          <a:off x="0" y="0"/>
-          <a:ext cx="0" cy="0"/>
-          <a:chOff x="0" y="0"/>
-          <a:chExt cx="0" cy="0"/>
-        </a:xfrm>
-      </p:grpSpPr>
-      <p:graphicFrame>
-        <p:nvGraphicFramePr>
-          <p:cNvPr id="3" name="Diagram 2"/>
-          <p:cNvGraphicFramePr/>
-          <p:nvPr/>
-        </p:nvGraphicFramePr>
-        <p:xfrm>
-          <a:off x="65314" y="0"/>
-          <a:ext cx="12066815" cy="6858000"/>
-        </p:xfrm>
-        <a:graphic>
-          <a:graphicData uri="http://schemas.openxmlformats.org/drawingml/2006/diagram">
-            <dgm:relIds xmlns:dgm="http://schemas.openxmlformats.org/drawingml/2006/diagram" r:dm="rId1" r:lo="rId2" r:qs="rId3" r:cs="rId4"/>
-          </a:graphicData>
-        </a:graphic>
-      </p:graphicFrame>
-      <p:sp>
-        <p:nvSpPr>
-          <p:cNvPr id="4" name="TextBox 3"/>
+      <p:sp>
+        <p:nvSpPr>
+          <p:cNvPr id="2" name="TextBox 1"/>
           <p:cNvSpPr txBox="1"/>
           <p:nvPr/>
         </p:nvSpPr>
         <p:spPr>
           <a:xfrm>
-            <a:off x="365760" y="6263640"/>
+            <a:off x="365760" y="182880"/>
             <a:ext cx="11430000" cy="548640"/>
           </a:xfrm>
           <a:prstGeom prst="rect">
             <a:avLst/>
           </a:prstGeom>
-          <a:solidFill>
-            <a:srgbClr val="FFF6E0"/>
-          </a:solidFill>
+          <a:noFill/>
         </p:spPr>
         <p:txBody>
           <a:bodyPr wrap="square">
@@ -24656,13 +24606,749 @@
           <a:lstStyle/>
           <a:p>
             <a:r>
-              <a:rPr sz="1200">
-                <a:solidFill>
-                  <a:srgbClr val="805000"/>
+              <a:rPr sz="2100" b="1">
+                <a:solidFill>
+                  <a:srgbClr val="1F3B6E"/>
+                </a:solidFill>
+              </a:rPr>
+              <a:t>7 · 选择一个领域 Topic</a:t>
+            </a:r>
+          </a:p>
+        </p:txBody>
+      </p:sp>
+      <p:sp>
+        <p:nvSpPr>
+          <p:cNvPr id="3" name="TextBox 2"/>
+          <p:cNvSpPr txBox="1"/>
+          <p:nvPr/>
+        </p:nvSpPr>
+        <p:spPr>
+          <a:xfrm>
+            <a:off x="365760" y="914400"/>
+            <a:ext cx="5897880" cy="5760720"/>
+          </a:xfrm>
+          <a:prstGeom prst="rect">
+            <a:avLst/>
+          </a:prstGeom>
+          <a:noFill/>
+        </p:spPr>
+        <p:txBody>
+          <a:bodyPr wrap="square">
+            <a:spAutoFit/>
+          </a:bodyPr>
+          <a:lstStyle/>
+          <a:p>
+            <a:pPr>
+              <a:spcAft>
+                <a:spcPts val="400"/>
+              </a:spcAft>
+            </a:pPr>
+            <a:r>
+              <a:rPr sz="1400">
+                <a:solidFill>
+                  <a:srgbClr val="202020"/>
+                </a:solidFill>
+              </a:rPr>
+              <a:t>Topic: Choose either a SPORT/INDUSTRY or a COMMERCIAL DOMAIN</a:t>
+            </a:r>
+          </a:p>
+          <a:p>
+            <a:pPr>
+              <a:spcAft>
+                <a:spcPts val="400"/>
+              </a:spcAft>
+            </a:pPr>
+          </a:p>
+          <a:p>
+            <a:pPr>
+              <a:spcAft>
+                <a:spcPts val="400"/>
+              </a:spcAft>
+            </a:pPr>
+            <a:r>
+              <a:rPr sz="1400">
+                <a:solidFill>
+                  <a:srgbClr val="202020"/>
+                </a:solidFill>
+              </a:rPr>
+              <a:t>1. A particular sport or industry</a:t>
+            </a:r>
+          </a:p>
+          <a:p>
+            <a:pPr>
+              <a:spcAft>
+                <a:spcPts val="400"/>
+              </a:spcAft>
+            </a:pPr>
+            <a:r>
+              <a:rPr sz="1400">
+                <a:solidFill>
+                  <a:srgbClr val="202020"/>
+                </a:solidFill>
+              </a:rPr>
+              <a:t>   · Type of sport: Football / Cricket / Boxing / Basketball / Baseball / E-sports</a:t>
+            </a:r>
+          </a:p>
+          <a:p>
+            <a:pPr>
+              <a:spcAft>
+                <a:spcPts val="400"/>
+              </a:spcAft>
+            </a:pPr>
+            <a:r>
+              <a:rPr sz="1400">
+                <a:solidFill>
+                  <a:srgbClr val="202020"/>
+                </a:solidFill>
+              </a:rPr>
+              <a:t>   · Industry: Sports apparel or equipment / Sports betting</a:t>
+            </a:r>
+          </a:p>
+          <a:p>
+            <a:pPr>
+              <a:spcAft>
+                <a:spcPts val="400"/>
+              </a:spcAft>
+            </a:pPr>
+          </a:p>
+          <a:p>
+            <a:pPr>
+              <a:spcAft>
+                <a:spcPts val="400"/>
+              </a:spcAft>
+            </a:pPr>
+            <a:r>
+              <a:rPr sz="1400">
+                <a:solidFill>
+                  <a:srgbClr val="202020"/>
+                </a:solidFill>
+              </a:rPr>
+              <a:t>2. Use of AI-based technology in commercial domain</a:t>
+            </a:r>
+          </a:p>
+          <a:p>
+            <a:pPr>
+              <a:spcAft>
+                <a:spcPts val="400"/>
+              </a:spcAft>
+            </a:pPr>
+            <a:r>
+              <a:rPr sz="1400">
+                <a:solidFill>
+                  <a:srgbClr val="202020"/>
+                </a:solidFill>
+              </a:rPr>
+              <a:t>   · Ticketing / Fan engagement / Customer engagement / Fantasy leagues / Sponsorship evaluation</a:t>
+            </a:r>
+          </a:p>
+          <a:p>
+            <a:pPr>
+              <a:spcAft>
+                <a:spcPts val="400"/>
+              </a:spcAft>
+            </a:pPr>
+          </a:p>
+          <a:p>
+            <a:pPr>
+              <a:spcAft>
+                <a:spcPts val="400"/>
+              </a:spcAft>
+            </a:pPr>
+            <a:r>
+              <a:rPr sz="1400">
+                <a:solidFill>
+                  <a:srgbClr val="202020"/>
+                </a:solidFill>
+              </a:rPr>
+              <a:t>Areas AI-based technology can be used:</a:t>
+            </a:r>
+          </a:p>
+          <a:p>
+            <a:pPr>
+              <a:spcAft>
+                <a:spcPts val="400"/>
+              </a:spcAft>
+            </a:pPr>
+            <a:r>
+              <a:rPr sz="1400">
+                <a:solidFill>
+                  <a:srgbClr val="202020"/>
+                </a:solidFill>
+              </a:rPr>
+              <a:t>   · Personalised training &amp; injury prevention</a:t>
+            </a:r>
+          </a:p>
+          <a:p>
+            <a:pPr>
+              <a:spcAft>
+                <a:spcPts val="400"/>
+              </a:spcAft>
+            </a:pPr>
+            <a:r>
+              <a:rPr sz="1400">
+                <a:solidFill>
+                  <a:srgbClr val="202020"/>
+                </a:solidFill>
+              </a:rPr>
+              <a:t>   · Performance analysis &amp; technique refinement</a:t>
+            </a:r>
+          </a:p>
+          <a:p>
+            <a:pPr>
+              <a:spcAft>
+                <a:spcPts val="400"/>
+              </a:spcAft>
+            </a:pPr>
+            <a:r>
+              <a:rPr sz="1400">
+                <a:solidFill>
+                  <a:srgbClr val="202020"/>
+                </a:solidFill>
+              </a:rPr>
+              <a:t>   · Advances in talent identification</a:t>
+            </a:r>
+          </a:p>
+          <a:p>
+            <a:pPr>
+              <a:spcAft>
+                <a:spcPts val="400"/>
+              </a:spcAft>
+            </a:pPr>
+            <a:r>
+              <a:rPr sz="1400">
+                <a:solidFill>
+                  <a:srgbClr val="202020"/>
+                </a:solidFill>
+              </a:rPr>
+              <a:t>   · Game plans / tactics for matches</a:t>
+            </a:r>
+          </a:p>
+          <a:p>
+            <a:pPr>
+              <a:spcAft>
+                <a:spcPts val="400"/>
+              </a:spcAft>
+            </a:pPr>
+            <a:r>
+              <a:rPr sz="1400">
+                <a:solidFill>
+                  <a:srgbClr val="202020"/>
+                </a:solidFill>
+              </a:rPr>
+              <a:t>   · Personalisation of content</a:t>
+            </a:r>
+          </a:p>
+          <a:p>
+            <a:pPr>
+              <a:spcAft>
+                <a:spcPts val="400"/>
+              </a:spcAft>
+            </a:pPr>
+            <a:r>
+              <a:rPr sz="1400">
+                <a:solidFill>
+                  <a:srgbClr val="202020"/>
+                </a:solidFill>
+              </a:rPr>
+              <a:t>   · Automated sports journalism</a:t>
+            </a:r>
+          </a:p>
+          <a:p>
+            <a:pPr>
+              <a:spcAft>
+                <a:spcPts val="400"/>
+              </a:spcAft>
+            </a:pPr>
+            <a:r>
+              <a:rPr sz="1400">
+                <a:solidFill>
+                  <a:srgbClr val="202020"/>
+                </a:solidFill>
+              </a:rPr>
+              <a:t>   · Optimisation of broadcasts</a:t>
+            </a:r>
+          </a:p>
+          <a:p>
+            <a:pPr>
+              <a:spcAft>
+                <a:spcPts val="400"/>
+              </a:spcAft>
+            </a:pPr>
+            <a:r>
+              <a:rPr sz="1400">
+                <a:solidFill>
+                  <a:srgbClr val="202020"/>
+                </a:solidFill>
+              </a:rPr>
+              <a:t>   · Fan engagement &amp; marketing</a:t>
+            </a:r>
+          </a:p>
+          <a:p>
+            <a:pPr>
+              <a:spcAft>
+                <a:spcPts val="400"/>
+              </a:spcAft>
+            </a:pPr>
+            <a:r>
+              <a:rPr sz="1400">
+                <a:solidFill>
+                  <a:srgbClr val="202020"/>
+                </a:solidFill>
+              </a:rPr>
+              <a:t>   · Automated refereeing</a:t>
+            </a:r>
+          </a:p>
+          <a:p>
+            <a:pPr>
+              <a:spcAft>
+                <a:spcPts val="400"/>
+              </a:spcAft>
+            </a:pPr>
+            <a:r>
+              <a:rPr sz="1400">
+                <a:solidFill>
+                  <a:srgbClr val="202020"/>
+                </a:solidFill>
+              </a:rPr>
+              <a:t>   · Event security / abuse</a:t>
+            </a:r>
+          </a:p>
+          <a:p>
+            <a:pPr>
+              <a:spcAft>
+                <a:spcPts val="400"/>
+              </a:spcAft>
+            </a:pPr>
+            <a:r>
+              <a:rPr sz="1400">
+                <a:solidFill>
+                  <a:srgbClr val="202020"/>
+                </a:solidFill>
+              </a:rPr>
+              <a:t>   · Sustainability</a:t>
+            </a:r>
+          </a:p>
+        </p:txBody>
+      </p:sp>
+      <p:sp>
+        <p:nvSpPr>
+          <p:cNvPr id="4" name="TextBox 3"/>
+          <p:cNvSpPr txBox="1"/>
+          <p:nvPr/>
+        </p:nvSpPr>
+        <p:spPr>
+          <a:xfrm>
+            <a:off x="6400800" y="914400"/>
+            <a:ext cx="5394960" cy="5760720"/>
+          </a:xfrm>
+          <a:prstGeom prst="rect">
+            <a:avLst/>
+          </a:prstGeom>
+          <a:solidFill>
+            <a:srgbClr val="F4F6FB"/>
+          </a:solidFill>
+        </p:spPr>
+        <p:txBody>
+          <a:bodyPr wrap="square" lIns="137160" rIns="137160" tIns="91440" bIns="91440">
+            <a:spAutoFit/>
+          </a:bodyPr>
+          <a:lstStyle/>
+          <a:p>
+            <a:pPr>
+              <a:spcAft>
+                <a:spcPts val="500"/>
+              </a:spcAft>
+            </a:pPr>
+            <a:r>
+              <a:rPr sz="1400">
+                <a:solidFill>
+                  <a:srgbClr val="333333"/>
                 </a:solidFill>
                 <a:latin typeface="Microsoft YaHei"/>
               </a:rPr>
-              <a:t>中译：（本页为纯图片/背景页，无文字内容）</a:t>
+              <a:t>选择一个领域（主题）</a:t>
+            </a:r>
+          </a:p>
+          <a:p>
+            <a:pPr>
+              <a:spcAft>
+                <a:spcPts val="500"/>
+              </a:spcAft>
+            </a:pPr>
+          </a:p>
+          <a:p>
+            <a:pPr>
+              <a:spcAft>
+                <a:spcPts val="500"/>
+              </a:spcAft>
+            </a:pPr>
+            <a:r>
+              <a:rPr sz="1400">
+                <a:solidFill>
+                  <a:srgbClr val="333333"/>
+                </a:solidFill>
+                <a:latin typeface="Microsoft YaHei"/>
+              </a:rPr>
+              <a:t>选「运动/行业」或「商业领域」其一：</a:t>
+            </a:r>
+          </a:p>
+          <a:p>
+            <a:pPr>
+              <a:spcAft>
+                <a:spcPts val="500"/>
+              </a:spcAft>
+            </a:pPr>
+          </a:p>
+          <a:p>
+            <a:pPr>
+              <a:spcAft>
+                <a:spcPts val="500"/>
+              </a:spcAft>
+            </a:pPr>
+            <a:r>
+              <a:rPr sz="1400">
+                <a:solidFill>
+                  <a:srgbClr val="333333"/>
+                </a:solidFill>
+                <a:latin typeface="Microsoft YaHei"/>
+              </a:rPr>
+              <a:t>1. 某个运动或行业</a:t>
+            </a:r>
+          </a:p>
+          <a:p>
+            <a:pPr>
+              <a:spcAft>
+                <a:spcPts val="500"/>
+              </a:spcAft>
+            </a:pPr>
+            <a:r>
+              <a:rPr sz="1400">
+                <a:solidFill>
+                  <a:srgbClr val="333333"/>
+                </a:solidFill>
+                <a:latin typeface="Microsoft YaHei"/>
+              </a:rPr>
+              <a:t>   · 运动类型：足球/板球/拳击/篮球/棒球/电竞</a:t>
+            </a:r>
+          </a:p>
+          <a:p>
+            <a:pPr>
+              <a:spcAft>
+                <a:spcPts val="500"/>
+              </a:spcAft>
+            </a:pPr>
+            <a:r>
+              <a:rPr sz="1400">
+                <a:solidFill>
+                  <a:srgbClr val="333333"/>
+                </a:solidFill>
+                <a:latin typeface="Microsoft YaHei"/>
+              </a:rPr>
+              <a:t>   · 行业：运动服装装备/体育博彩</a:t>
+            </a:r>
+          </a:p>
+          <a:p>
+            <a:pPr>
+              <a:spcAft>
+                <a:spcPts val="500"/>
+              </a:spcAft>
+            </a:pPr>
+          </a:p>
+          <a:p>
+            <a:pPr>
+              <a:spcAft>
+                <a:spcPts val="500"/>
+              </a:spcAft>
+            </a:pPr>
+            <a:r>
+              <a:rPr sz="1400">
+                <a:solidFill>
+                  <a:srgbClr val="333333"/>
+                </a:solidFill>
+                <a:latin typeface="Microsoft YaHei"/>
+              </a:rPr>
+              <a:t>2. 商业领域的 AI 技术应用</a:t>
+            </a:r>
+          </a:p>
+          <a:p>
+            <a:pPr>
+              <a:spcAft>
+                <a:spcPts val="500"/>
+              </a:spcAft>
+            </a:pPr>
+            <a:r>
+              <a:rPr sz="1400">
+                <a:solidFill>
+                  <a:srgbClr val="333333"/>
+                </a:solidFill>
+                <a:latin typeface="Microsoft YaHei"/>
+              </a:rPr>
+              <a:t>   · 票务/球迷互动/客户互动/梦幻联赛/赞助评估</a:t>
+            </a:r>
+          </a:p>
+          <a:p>
+            <a:pPr>
+              <a:spcAft>
+                <a:spcPts val="500"/>
+              </a:spcAft>
+            </a:pPr>
+          </a:p>
+          <a:p>
+            <a:pPr>
+              <a:spcAft>
+                <a:spcPts val="500"/>
+              </a:spcAft>
+            </a:pPr>
+            <a:r>
+              <a:rPr sz="1400">
+                <a:solidFill>
+                  <a:srgbClr val="333333"/>
+                </a:solidFill>
+                <a:latin typeface="Microsoft YaHei"/>
+              </a:rPr>
+              <a:t>AI 技术可应用领域：</a:t>
+            </a:r>
+          </a:p>
+          <a:p>
+            <a:pPr>
+              <a:spcAft>
+                <a:spcPts val="500"/>
+              </a:spcAft>
+            </a:pPr>
+            <a:r>
+              <a:rPr sz="1400">
+                <a:solidFill>
+                  <a:srgbClr val="333333"/>
+                </a:solidFill>
+                <a:latin typeface="Microsoft YaHei"/>
+              </a:rPr>
+              <a:t>   · 个性化训练与伤病预防</a:t>
+            </a:r>
+          </a:p>
+          <a:p>
+            <a:pPr>
+              <a:spcAft>
+                <a:spcPts val="500"/>
+              </a:spcAft>
+            </a:pPr>
+            <a:r>
+              <a:rPr sz="1400">
+                <a:solidFill>
+                  <a:srgbClr val="333333"/>
+                </a:solidFill>
+                <a:latin typeface="Microsoft YaHei"/>
+              </a:rPr>
+              <a:t>   · 表现分析与技术优化</a:t>
+            </a:r>
+          </a:p>
+          <a:p>
+            <a:pPr>
+              <a:spcAft>
+                <a:spcPts val="500"/>
+              </a:spcAft>
+            </a:pPr>
+            <a:r>
+              <a:rPr sz="1400">
+                <a:solidFill>
+                  <a:srgbClr val="333333"/>
+                </a:solidFill>
+                <a:latin typeface="Microsoft YaHei"/>
+              </a:rPr>
+              <a:t>   · 人才识别进展</a:t>
+            </a:r>
+          </a:p>
+          <a:p>
+            <a:pPr>
+              <a:spcAft>
+                <a:spcPts val="500"/>
+              </a:spcAft>
+            </a:pPr>
+            <a:r>
+              <a:rPr sz="1400">
+                <a:solidFill>
+                  <a:srgbClr val="333333"/>
+                </a:solidFill>
+                <a:latin typeface="Microsoft YaHei"/>
+              </a:rPr>
+              <a:t>   · 比赛战术/战略运用</a:t>
+            </a:r>
+          </a:p>
+          <a:p>
+            <a:pPr>
+              <a:spcAft>
+                <a:spcPts val="500"/>
+              </a:spcAft>
+            </a:pPr>
+            <a:r>
+              <a:rPr sz="1400">
+                <a:solidFill>
+                  <a:srgbClr val="333333"/>
+                </a:solidFill>
+                <a:latin typeface="Microsoft YaHei"/>
+              </a:rPr>
+              <a:t>   · 内容个性化</a:t>
+            </a:r>
+          </a:p>
+          <a:p>
+            <a:pPr>
+              <a:spcAft>
+                <a:spcPts val="500"/>
+              </a:spcAft>
+            </a:pPr>
+            <a:r>
+              <a:rPr sz="1400">
+                <a:solidFill>
+                  <a:srgbClr val="333333"/>
+                </a:solidFill>
+                <a:latin typeface="Microsoft YaHei"/>
+              </a:rPr>
+              <a:t>   · 体育新闻自动化</a:t>
+            </a:r>
+          </a:p>
+          <a:p>
+            <a:pPr>
+              <a:spcAft>
+                <a:spcPts val="500"/>
+              </a:spcAft>
+            </a:pPr>
+            <a:r>
+              <a:rPr sz="1400">
+                <a:solidFill>
+                  <a:srgbClr val="333333"/>
+                </a:solidFill>
+                <a:latin typeface="Microsoft YaHei"/>
+              </a:rPr>
+              <a:t>   · 转播优化</a:t>
+            </a:r>
+          </a:p>
+          <a:p>
+            <a:pPr>
+              <a:spcAft>
+                <a:spcPts val="500"/>
+              </a:spcAft>
+            </a:pPr>
+            <a:r>
+              <a:rPr sz="1400">
+                <a:solidFill>
+                  <a:srgbClr val="333333"/>
+                </a:solidFill>
+                <a:latin typeface="Microsoft YaHei"/>
+              </a:rPr>
+              <a:t>   · 球迷互动与营销</a:t>
+            </a:r>
+          </a:p>
+          <a:p>
+            <a:pPr>
+              <a:spcAft>
+                <a:spcPts val="500"/>
+              </a:spcAft>
+            </a:pPr>
+            <a:r>
+              <a:rPr sz="1400">
+                <a:solidFill>
+                  <a:srgbClr val="333333"/>
+                </a:solidFill>
+                <a:latin typeface="Microsoft YaHei"/>
+              </a:rPr>
+              <a:t>   · 自动裁判</a:t>
+            </a:r>
+          </a:p>
+          <a:p>
+            <a:pPr>
+              <a:spcAft>
+                <a:spcPts val="500"/>
+              </a:spcAft>
+            </a:pPr>
+            <a:r>
+              <a:rPr sz="1400">
+                <a:solidFill>
+                  <a:srgbClr val="333333"/>
+                </a:solidFill>
+                <a:latin typeface="Microsoft YaHei"/>
+              </a:rPr>
+              <a:t>   · 赛事安全/防滥用</a:t>
+            </a:r>
+          </a:p>
+          <a:p>
+            <a:pPr>
+              <a:spcAft>
+                <a:spcPts val="500"/>
+              </a:spcAft>
+            </a:pPr>
+            <a:r>
+              <a:rPr sz="1400">
+                <a:solidFill>
+                  <a:srgbClr val="333333"/>
+                </a:solidFill>
+                <a:latin typeface="Microsoft YaHei"/>
+              </a:rPr>
+              <a:t>   · 可持续性</a:t>
+            </a:r>
+          </a:p>
+        </p:txBody>
+      </p:sp>
+      <p:sp>
+        <p:nvSpPr>
+          <p:cNvPr id="5" name="TextBox 4"/>
+          <p:cNvSpPr txBox="1"/>
+          <p:nvPr/>
+        </p:nvSpPr>
+        <p:spPr>
+          <a:xfrm>
+            <a:off x="365760" y="713232"/>
+            <a:ext cx="1828800" cy="237744"/>
+          </a:xfrm>
+          <a:prstGeom prst="rect">
+            <a:avLst/>
+          </a:prstGeom>
+          <a:noFill/>
+        </p:spPr>
+        <p:txBody>
+          <a:bodyPr wrap="none">
+            <a:spAutoFit/>
+          </a:bodyPr>
+          <a:lstStyle/>
+          <a:p>
+            <a:r>
+              <a:rPr sz="1000" b="1">
+                <a:solidFill>
+                  <a:srgbClr val="404040"/>
+                </a:solidFill>
+              </a:rPr>
+              <a:t>EN ▶</a:t>
+            </a:r>
+          </a:p>
+        </p:txBody>
+      </p:sp>
+      <p:sp>
+        <p:nvSpPr>
+          <p:cNvPr id="6" name="TextBox 5"/>
+          <p:cNvSpPr txBox="1"/>
+          <p:nvPr/>
+        </p:nvSpPr>
+        <p:spPr>
+          <a:xfrm>
+            <a:off x="6400800" y="713232"/>
+            <a:ext cx="1828800" cy="237744"/>
+          </a:xfrm>
+          <a:prstGeom prst="rect">
+            <a:avLst/>
+          </a:prstGeom>
+          <a:noFill/>
+        </p:spPr>
+        <p:txBody>
+          <a:bodyPr wrap="none">
+            <a:spAutoFit/>
+          </a:bodyPr>
+          <a:lstStyle/>
+          <a:p>
+            <a:r>
+              <a:rPr sz="1000" b="1">
+                <a:solidFill>
+                  <a:srgbClr val="404040"/>
+                </a:solidFill>
+              </a:rPr>
+              <a:t>中文 ▶</a:t>
             </a:r>
           </a:p>
         </p:txBody>

</xml_diff>